<commit_message>
WS4A: slide titles state the conclusion
Each slide title now says what the slide concludes rather than what it contains, so
the argument survives a reader who only skims titles. The number or caveat a short
title has to drop moves to a subtitle line beneath it.

Rebuilt deck and PDF preview; the builder README records the convention.

Co-Authored-By: Claude Opus 5 (1M context) <noreply@anthropic.com>
Claude-Session: https://claude.ai/code/session_01ErS43gfbvnsANcpxm6McXS
</commit_message>
<xml_diff>
--- a/WS4A_presentation_pack/WS4A_slides.pptx
+++ b/WS4A_presentation_pack/WS4A_slides.pptx
@@ -4210,8 +4210,8 @@
         </p:nvSpPr>
         <p:spPr>
           <a:xfrm>
-            <a:off x="822960" y="2011680"/>
-            <a:ext cx="10515600" cy="1097280"/>
+            <a:off x="822960" y="1874519"/>
+            <a:ext cx="10515600" cy="1188720"/>
           </a:xfrm>
           <a:prstGeom prst="rect">
             <a:avLst/>
@@ -4236,7 +4236,7 @@
                 </a:solidFill>
                 <a:latin typeface="Calibri"/>
               </a:rPr>
-              <a:t>Does the microscope tell us anything</a:t>
+              <a:t>Cell Painting tells you about mechanism —</a:t>
             </a:r>
           </a:p>
           <a:p>
@@ -4252,7 +4252,7 @@
                 </a:solidFill>
                 <a:latin typeface="Calibri"/>
               </a:rPr>
-              <a:t>chemistry doesn't already?</a:t>
+              <a:t>not about toxicity</a:t>
             </a:r>
           </a:p>
         </p:txBody>
@@ -4265,8 +4265,8 @@
         </p:nvSpPr>
         <p:spPr>
           <a:xfrm>
-            <a:off x="822960" y="3657600"/>
-            <a:ext cx="10515600" cy="1463040"/>
+            <a:off x="822960" y="3154680"/>
+            <a:ext cx="10515600" cy="457200"/>
           </a:xfrm>
           <a:prstGeom prst="rect">
             <a:avLst/>
@@ -4285,15 +4285,38 @@
               </a:spcAft>
             </a:pPr>
             <a:r>
-              <a:rPr sz="1500" b="0" i="0">
-                <a:solidFill>
-                  <a:srgbClr val="5A5A58"/>
-                </a:solidFill>
-                <a:latin typeface="Calibri"/>
-              </a:rPr>
-              <a:t>WS4A · cross-modal integration · HepG2</a:t>
-            </a:r>
-          </a:p>
+              <a:rPr sz="1700" b="1" i="0">
+                <a:solidFill>
+                  <a:srgbClr val="2A78D6"/>
+                </a:solidFill>
+                <a:latin typeface="Calibri"/>
+              </a:rPr>
+              <a:t>…and it beats chemical structure, which is free, at doing so.</a:t>
+            </a:r>
+          </a:p>
+        </p:txBody>
+      </p:sp>
+      <p:sp>
+        <p:nvSpPr>
+          <p:cNvPr id="4" name="TextBox 3"/>
+          <p:cNvSpPr txBox="1"/>
+          <p:nvPr/>
+        </p:nvSpPr>
+        <p:spPr>
+          <a:xfrm>
+            <a:off x="822960" y="3794760"/>
+            <a:ext cx="10515600" cy="1005840"/>
+          </a:xfrm>
+          <a:prstGeom prst="rect">
+            <a:avLst/>
+          </a:prstGeom>
+          <a:noFill/>
+        </p:spPr>
+        <p:txBody>
+          <a:bodyPr wrap="square" anchor="t">
+            <a:spAutoFit/>
+          </a:bodyPr>
+          <a:lstStyle/>
           <a:p>
             <a:pPr algn="l">
               <a:spcAft>
@@ -4307,6 +4330,22 @@
                 </a:solidFill>
                 <a:latin typeface="Calibri"/>
               </a:rPr>
+              <a:t>WS4A · cross-modal integration · HepG2</a:t>
+            </a:r>
+          </a:p>
+          <a:p>
+            <a:pPr algn="l">
+              <a:spcAft>
+                <a:spcPts val="400"/>
+              </a:spcAft>
+            </a:pPr>
+            <a:r>
+              <a:rPr sz="1500" b="0" i="0">
+                <a:solidFill>
+                  <a:srgbClr val="5A5A58"/>
+                </a:solidFill>
+                <a:latin typeface="Calibri"/>
+              </a:rPr>
               <a:t>119 compounds · morphology (636) × gene expression (41,780) × chemical structure (1,024)</a:t>
             </a:r>
           </a:p>
@@ -4314,7 +4353,7 @@
       </p:sp>
       <p:sp>
         <p:nvSpPr>
-          <p:cNvPr id="4" name="TextBox 3"/>
+          <p:cNvPr id="5" name="TextBox 4"/>
           <p:cNvSpPr txBox="1"/>
           <p:nvPr/>
         </p:nvSpPr>
@@ -4401,7 +4440,7 @@
         </p:nvSpPr>
         <p:spPr>
           <a:xfrm>
-            <a:off x="457200" y="146304"/>
+            <a:off x="457200" y="128016"/>
             <a:ext cx="11338560" cy="274320"/>
           </a:xfrm>
           <a:prstGeom prst="rect">
@@ -4440,8 +4479,8 @@
         </p:nvSpPr>
         <p:spPr>
           <a:xfrm>
-            <a:off x="457200" y="402336"/>
-            <a:ext cx="11338560" cy="731520"/>
+            <a:off x="457200" y="365760"/>
+            <a:ext cx="11338560" cy="502920"/>
           </a:xfrm>
           <a:prstGeom prst="rect">
             <a:avLst/>
@@ -4460,20 +4499,59 @@
               </a:spcAft>
             </a:pPr>
             <a:r>
-              <a:rPr sz="2000" b="1" i="0">
+              <a:rPr sz="2600" b="1" i="0">
                 <a:solidFill>
                   <a:srgbClr val="1A1A1A"/>
                 </a:solidFill>
                 <a:latin typeface="Calibri"/>
               </a:rPr>
-              <a:t>Six questions · five kinds of data · four models · every setting chosen on data the score never sees.</a:t>
+              <a:t>Only 119 drugs — so every score gets a scrambled-label twin</a:t>
+            </a:r>
+          </a:p>
+        </p:txBody>
+      </p:sp>
+      <p:sp>
+        <p:nvSpPr>
+          <p:cNvPr id="4" name="TextBox 3"/>
+          <p:cNvSpPr txBox="1"/>
+          <p:nvPr/>
+        </p:nvSpPr>
+        <p:spPr>
+          <a:xfrm>
+            <a:off x="457200" y="896112"/>
+            <a:ext cx="11338560" cy="320040"/>
+          </a:xfrm>
+          <a:prstGeom prst="rect">
+            <a:avLst/>
+          </a:prstGeom>
+          <a:noFill/>
+        </p:spPr>
+        <p:txBody>
+          <a:bodyPr wrap="square" anchor="t">
+            <a:spAutoFit/>
+          </a:bodyPr>
+          <a:lstStyle/>
+          <a:p>
+            <a:pPr algn="l">
+              <a:spcAft>
+                <a:spcPts val="400"/>
+              </a:spcAft>
+            </a:pPr>
+            <a:r>
+              <a:rPr sz="1400" b="0" i="0">
+                <a:solidFill>
+                  <a:srgbClr val="5A5A58"/>
+                </a:solidFill>
+                <a:latin typeface="Calibri"/>
+              </a:rPr>
+              <a:t>Six questions · five kinds of data · four model families · every setting chosen on drugs the score never sees.</a:t>
             </a:r>
           </a:p>
         </p:txBody>
       </p:sp>
       <p:pic>
         <p:nvPicPr>
-          <p:cNvPr id="4" name="Picture 3" descr="SLIDE_0_how_it_was_trained.png"/>
+          <p:cNvPr id="5" name="Picture 4" descr="SLIDE_0_how_it_was_trained.png"/>
           <p:cNvPicPr>
             <a:picLocks noChangeAspect="1"/>
           </p:cNvPicPr>
@@ -4487,8 +4565,8 @@
         </p:blipFill>
         <p:spPr>
           <a:xfrm>
-            <a:off x="3709362" y="1188720"/>
-            <a:ext cx="4788516" cy="2514600"/>
+            <a:off x="3883489" y="1353312"/>
+            <a:ext cx="4440261" cy="2331720"/>
           </a:xfrm>
           <a:prstGeom prst="rect">
             <a:avLst/>
@@ -4497,14 +4575,14 @@
       </p:pic>
       <p:sp>
         <p:nvSpPr>
-          <p:cNvPr id="5" name="TextBox 4"/>
+          <p:cNvPr id="6" name="TextBox 5"/>
           <p:cNvSpPr txBox="1"/>
           <p:nvPr/>
         </p:nvSpPr>
         <p:spPr>
           <a:xfrm>
-            <a:off x="457200" y="3867911"/>
-            <a:ext cx="11338560" cy="2852928"/>
+            <a:off x="457200" y="3849623"/>
+            <a:ext cx="11338560" cy="2871216"/>
           </a:xfrm>
           <a:prstGeom prst="rect">
             <a:avLst/>
@@ -4652,7 +4730,7 @@
         </p:nvSpPr>
         <p:spPr>
           <a:xfrm>
-            <a:off x="457200" y="146304"/>
+            <a:off x="457200" y="128016"/>
             <a:ext cx="11338560" cy="274320"/>
           </a:xfrm>
           <a:prstGeom prst="rect">
@@ -4691,8 +4769,8 @@
         </p:nvSpPr>
         <p:spPr>
           <a:xfrm>
-            <a:off x="457200" y="402336"/>
-            <a:ext cx="11338560" cy="731520"/>
+            <a:off x="457200" y="365760"/>
+            <a:ext cx="11338560" cy="502920"/>
           </a:xfrm>
           <a:prstGeom prst="rect">
             <a:avLst/>
@@ -4711,20 +4789,59 @@
               </a:spcAft>
             </a:pPr>
             <a:r>
-              <a:rPr sz="2000" b="1" i="0">
+              <a:rPr sz="2600" b="1" i="0">
                 <a:solidFill>
                   <a:srgbClr val="1A1A1A"/>
                 </a:solidFill>
                 <a:latin typeface="Calibri"/>
               </a:rPr>
-              <a:t>Morphology beats chemistry for mechanism — and adds nothing for toxicity.</a:t>
+              <a:t>Morphology beats chemistry — for mechanism only</a:t>
+            </a:r>
+          </a:p>
+        </p:txBody>
+      </p:sp>
+      <p:sp>
+        <p:nvSpPr>
+          <p:cNvPr id="4" name="TextBox 3"/>
+          <p:cNvSpPr txBox="1"/>
+          <p:nvPr/>
+        </p:nvSpPr>
+        <p:spPr>
+          <a:xfrm>
+            <a:off x="457200" y="896112"/>
+            <a:ext cx="11338560" cy="320040"/>
+          </a:xfrm>
+          <a:prstGeom prst="rect">
+            <a:avLst/>
+          </a:prstGeom>
+          <a:noFill/>
+        </p:spPr>
+        <p:txBody>
+          <a:bodyPr wrap="square" anchor="t">
+            <a:spAutoFit/>
+          </a:bodyPr>
+          <a:lstStyle/>
+          <a:p>
+            <a:pPr algn="l">
+              <a:spcAft>
+                <a:spcPts val="400"/>
+              </a:spcAft>
+            </a:pPr>
+            <a:r>
+              <a:rPr sz="1400" b="0" i="0">
+                <a:solidFill>
+                  <a:srgbClr val="5A5A58"/>
+                </a:solidFill>
+                <a:latin typeface="Calibri"/>
+              </a:rPr>
+              <a:t>+0.143 over chemical structure for mechanism of action, all four models agreeing.  For all five toxicity endpoints it adds nothing.</a:t>
             </a:r>
           </a:p>
         </p:txBody>
       </p:sp>
       <p:pic>
         <p:nvPicPr>
-          <p:cNvPr id="4" name="Picture 3" descr="SLIDE_1_ALT_signal_map.png"/>
+          <p:cNvPr id="5" name="Picture 4" descr="SLIDE_1_ALT_signal_map.png"/>
           <p:cNvPicPr>
             <a:picLocks noChangeAspect="1"/>
           </p:cNvPicPr>
@@ -4738,8 +4855,8 @@
         </p:blipFill>
         <p:spPr>
           <a:xfrm>
-            <a:off x="3749085" y="1188720"/>
-            <a:ext cx="4709069" cy="2788920"/>
+            <a:off x="3903481" y="1353312"/>
+            <a:ext cx="4400277" cy="2606040"/>
           </a:xfrm>
           <a:prstGeom prst="rect">
             <a:avLst/>
@@ -4748,14 +4865,14 @@
       </p:pic>
       <p:sp>
         <p:nvSpPr>
-          <p:cNvPr id="5" name="TextBox 4"/>
+          <p:cNvPr id="6" name="TextBox 5"/>
           <p:cNvSpPr txBox="1"/>
           <p:nvPr/>
         </p:nvSpPr>
         <p:spPr>
           <a:xfrm>
-            <a:off x="457200" y="4142231"/>
-            <a:ext cx="11338560" cy="2578608"/>
+            <a:off x="457200" y="4123944"/>
+            <a:ext cx="11338560" cy="2596896"/>
           </a:xfrm>
           <a:prstGeom prst="rect">
             <a:avLst/>
@@ -4878,7 +4995,7 @@
         </p:nvSpPr>
         <p:spPr>
           <a:xfrm>
-            <a:off x="457200" y="146304"/>
+            <a:off x="457200" y="128016"/>
             <a:ext cx="11338560" cy="274320"/>
           </a:xfrm>
           <a:prstGeom prst="rect">
@@ -4917,8 +5034,8 @@
         </p:nvSpPr>
         <p:spPr>
           <a:xfrm>
-            <a:off x="457200" y="402336"/>
-            <a:ext cx="11338560" cy="731520"/>
+            <a:off x="457200" y="365760"/>
+            <a:ext cx="11338560" cy="502920"/>
           </a:xfrm>
           <a:prstGeom prst="rect">
             <a:avLst/>
@@ -4937,20 +5054,59 @@
               </a:spcAft>
             </a:pPr>
             <a:r>
-              <a:rPr sz="2000" b="1" i="0">
+              <a:rPr sz="2600" b="1" i="0">
                 <a:solidFill>
                   <a:srgbClr val="1A1A1A"/>
                 </a:solidFill>
                 <a:latin typeface="Calibri"/>
               </a:rPr>
-              <a:t>Selecting 2,000 genes costs 16× what the leakage it was criticised for was worth.</a:t>
+              <a:t>Gene selection, not the modality, is why expression lost</a:t>
+            </a:r>
+          </a:p>
+        </p:txBody>
+      </p:sp>
+      <p:sp>
+        <p:nvSpPr>
+          <p:cNvPr id="4" name="TextBox 3"/>
+          <p:cNvSpPr txBox="1"/>
+          <p:nvPr/>
+        </p:nvSpPr>
+        <p:spPr>
+          <a:xfrm>
+            <a:off x="457200" y="896112"/>
+            <a:ext cx="11338560" cy="320040"/>
+          </a:xfrm>
+          <a:prstGeom prst="rect">
+            <a:avLst/>
+          </a:prstGeom>
+          <a:noFill/>
+        </p:spPr>
+        <p:txBody>
+          <a:bodyPr wrap="square" anchor="t">
+            <a:spAutoFit/>
+          </a:bodyPr>
+          <a:lstStyle/>
+          <a:p>
+            <a:pPr algn="l">
+              <a:spcAft>
+                <a:spcPts val="400"/>
+              </a:spcAft>
+            </a:pPr>
+            <a:r>
+              <a:rPr sz="1400" b="0" i="0">
+                <a:solidFill>
+                  <a:srgbClr val="5A5A58"/>
+                </a:solidFill>
+                <a:latin typeface="Calibri"/>
+              </a:rPr>
+              <a:t>Dropping to 2,000 highly variable genes costs 16× what the leakage it is usually criticised for was worth.</a:t>
             </a:r>
           </a:p>
         </p:txBody>
       </p:sp>
       <p:pic>
         <p:nvPicPr>
-          <p:cNvPr id="4" name="Picture 3" descr="SLIDE_2_hvg_selection_cost.png"/>
+          <p:cNvPr id="5" name="Picture 4" descr="SLIDE_2_hvg_selection_cost.png"/>
           <p:cNvPicPr>
             <a:picLocks noChangeAspect="1"/>
           </p:cNvPicPr>
@@ -4964,8 +5120,8 @@
         </p:blipFill>
         <p:spPr>
           <a:xfrm>
-            <a:off x="2828109" y="1188720"/>
-            <a:ext cx="6551022" cy="2697480"/>
+            <a:off x="3050177" y="1353312"/>
+            <a:ext cx="6106885" cy="2514600"/>
           </a:xfrm>
           <a:prstGeom prst="rect">
             <a:avLst/>
@@ -4974,14 +5130,14 @@
       </p:pic>
       <p:sp>
         <p:nvSpPr>
-          <p:cNvPr id="5" name="TextBox 4"/>
+          <p:cNvPr id="6" name="TextBox 5"/>
           <p:cNvSpPr txBox="1"/>
           <p:nvPr/>
         </p:nvSpPr>
         <p:spPr>
           <a:xfrm>
-            <a:off x="457200" y="4050791"/>
-            <a:ext cx="11338560" cy="2670048"/>
+            <a:off x="457200" y="4032504"/>
+            <a:ext cx="11338560" cy="2688335"/>
           </a:xfrm>
           <a:prstGeom prst="rect">
             <a:avLst/>
@@ -5104,7 +5260,7 @@
         </p:nvSpPr>
         <p:spPr>
           <a:xfrm>
-            <a:off x="457200" y="146304"/>
+            <a:off x="457200" y="128016"/>
             <a:ext cx="11338560" cy="274320"/>
           </a:xfrm>
           <a:prstGeom prst="rect">
@@ -5143,8 +5299,8 @@
         </p:nvSpPr>
         <p:spPr>
           <a:xfrm>
-            <a:off x="457200" y="402336"/>
-            <a:ext cx="11338560" cy="731520"/>
+            <a:off x="457200" y="365760"/>
+            <a:ext cx="11338560" cy="502920"/>
           </a:xfrm>
           <a:prstGeom prst="rect">
             <a:avLst/>
@@ -5163,20 +5319,59 @@
               </a:spcAft>
             </a:pPr>
             <a:r>
-              <a:rPr sz="2000" b="1" i="0">
+              <a:rPr sz="2600" b="1" i="0">
                 <a:solidFill>
                   <a:srgbClr val="1A1A1A"/>
                 </a:solidFill>
                 <a:latin typeface="Calibri"/>
               </a:rPr>
-              <a:t>Four model families that work differently agree on where the signal is.</a:t>
+              <a:t>Four different models, the same answer</a:t>
+            </a:r>
+          </a:p>
+        </p:txBody>
+      </p:sp>
+      <p:sp>
+        <p:nvSpPr>
+          <p:cNvPr id="4" name="TextBox 3"/>
+          <p:cNvSpPr txBox="1"/>
+          <p:nvPr/>
+        </p:nvSpPr>
+        <p:spPr>
+          <a:xfrm>
+            <a:off x="457200" y="896112"/>
+            <a:ext cx="11338560" cy="320040"/>
+          </a:xfrm>
+          <a:prstGeom prst="rect">
+            <a:avLst/>
+          </a:prstGeom>
+          <a:noFill/>
+        </p:spPr>
+        <p:txBody>
+          <a:bodyPr wrap="square" anchor="t">
+            <a:spAutoFit/>
+          </a:bodyPr>
+          <a:lstStyle/>
+          <a:p>
+            <a:pPr algn="l">
+              <a:spcAft>
+                <a:spcPts val="400"/>
+              </a:spcAft>
+            </a:pPr>
+            <a:r>
+              <a:rPr sz="1400" b="0" i="0">
+                <a:solidFill>
+                  <a:srgbClr val="5A5A58"/>
+                </a:solidFill>
+                <a:latin typeface="Calibri"/>
+              </a:rPr>
+              <a:t>Model families that fail in different ways agree on where the signal is — better evidence here than a p-value cross-validation cannot honestly give.</a:t>
             </a:r>
           </a:p>
         </p:txBody>
       </p:sp>
       <p:pic>
         <p:nvPicPr>
-          <p:cNvPr id="4" name="Picture 3" descr="SLIDE_3_models_agree.png"/>
+          <p:cNvPr id="5" name="Picture 4" descr="SLIDE_3_models_agree.png"/>
           <p:cNvPicPr>
             <a:picLocks noChangeAspect="1"/>
           </p:cNvPicPr>
@@ -5190,8 +5385,8 @@
         </p:blipFill>
         <p:spPr>
           <a:xfrm>
-            <a:off x="2473779" y="1188720"/>
-            <a:ext cx="7259682" cy="2606040"/>
+            <a:off x="2728504" y="1353312"/>
+            <a:ext cx="6750231" cy="2423160"/>
           </a:xfrm>
           <a:prstGeom prst="rect">
             <a:avLst/>
@@ -5200,14 +5395,14 @@
       </p:pic>
       <p:sp>
         <p:nvSpPr>
-          <p:cNvPr id="5" name="TextBox 4"/>
+          <p:cNvPr id="6" name="TextBox 5"/>
           <p:cNvSpPr txBox="1"/>
           <p:nvPr/>
         </p:nvSpPr>
         <p:spPr>
           <a:xfrm>
-            <a:off x="457200" y="3959352"/>
-            <a:ext cx="11338560" cy="2761487"/>
+            <a:off x="457200" y="3941063"/>
+            <a:ext cx="11338560" cy="2779776"/>
           </a:xfrm>
           <a:prstGeom prst="rect">
             <a:avLst/>
@@ -5330,8 +5525,8 @@
         </p:nvSpPr>
         <p:spPr>
           <a:xfrm>
-            <a:off x="548640" y="457200"/>
-            <a:ext cx="11155680" cy="548640"/>
+            <a:off x="548640" y="384048"/>
+            <a:ext cx="11155680" cy="502920"/>
           </a:xfrm>
           <a:prstGeom prst="rect">
             <a:avLst/>
@@ -5356,7 +5551,7 @@
                 </a:solidFill>
                 <a:latin typeface="Calibri"/>
               </a:rPr>
-              <a:t>What we can say — and what we cannot</a:t>
+              <a:t>Narrow claims, and the controls that made them narrow</a:t>
             </a:r>
           </a:p>
         </p:txBody>
@@ -5369,8 +5564,8 @@
         </p:nvSpPr>
         <p:spPr>
           <a:xfrm>
-            <a:off x="640080" y="1325880"/>
-            <a:ext cx="5394960" cy="4206240"/>
+            <a:off x="548640" y="932688"/>
+            <a:ext cx="11155680" cy="320040"/>
           </a:xfrm>
           <a:prstGeom prst="rect">
             <a:avLst/>
@@ -5391,251 +5586,11 @@
             <a:r>
               <a:rPr sz="1400" b="0" i="0">
                 <a:solidFill>
-                  <a:srgbClr val="1A1A1A"/>
-                </a:solidFill>
-                <a:latin typeface="Calibri"/>
-              </a:rPr>
-              <a:t>WE CAN SAY</a:t>
-            </a:r>
-          </a:p>
-          <a:p>
-            <a:pPr algn="l">
-              <a:spcAft>
-                <a:spcPts val="400"/>
-              </a:spcAft>
-            </a:pPr>
-            <a:r>
-              <a:rPr sz="1400" b="0" i="0">
-                <a:solidFill>
-                  <a:srgbClr val="1A1A1A"/>
-                </a:solidFill>
-                <a:latin typeface="Calibri"/>
-              </a:rPr>
-              <a:t/>
-            </a:r>
-          </a:p>
-          <a:p>
-            <a:pPr algn="l">
-              <a:spcAft>
-                <a:spcPts val="400"/>
-              </a:spcAft>
-            </a:pPr>
-            <a:r>
-              <a:rPr sz="1400" b="0" i="0">
-                <a:solidFill>
-                  <a:srgbClr val="1A1A1A"/>
-                </a:solidFill>
-                <a:latin typeface="Calibri"/>
-              </a:rPr>
-              <a:t>•  Morphology adds +0.143 over chemical</a:t>
-            </a:r>
-          </a:p>
-          <a:p>
-            <a:pPr algn="l">
-              <a:spcAft>
-                <a:spcPts val="400"/>
-              </a:spcAft>
-            </a:pPr>
-            <a:r>
-              <a:rPr sz="1400" b="0" i="0">
-                <a:solidFill>
-                  <a:srgbClr val="1A1A1A"/>
-                </a:solidFill>
-                <a:latin typeface="Calibri"/>
-              </a:rPr>
-              <a:t>    structure for mechanism, 4 of 4 models</a:t>
-            </a:r>
-          </a:p>
-          <a:p>
-            <a:pPr algn="l">
-              <a:spcAft>
-                <a:spcPts val="400"/>
-              </a:spcAft>
-            </a:pPr>
-            <a:r>
-              <a:rPr sz="1400" b="0" i="0">
-                <a:solidFill>
-                  <a:srgbClr val="1A1A1A"/>
-                </a:solidFill>
-                <a:latin typeface="Calibri"/>
-              </a:rPr>
-              <a:t/>
-            </a:r>
-          </a:p>
-          <a:p>
-            <a:pPr algn="l">
-              <a:spcAft>
-                <a:spcPts val="400"/>
-              </a:spcAft>
-            </a:pPr>
-            <a:r>
-              <a:rPr sz="1400" b="0" i="0">
-                <a:solidFill>
-                  <a:srgbClr val="1A1A1A"/>
-                </a:solidFill>
-                <a:latin typeface="Calibri"/>
-              </a:rPr>
-              <a:t>•  It adds nothing for the five toxicity</a:t>
-            </a:r>
-          </a:p>
-          <a:p>
-            <a:pPr algn="l">
-              <a:spcAft>
-                <a:spcPts val="400"/>
-              </a:spcAft>
-            </a:pPr>
-            <a:r>
-              <a:rPr sz="1400" b="0" i="0">
-                <a:solidFill>
-                  <a:srgbClr val="1A1A1A"/>
-                </a:solidFill>
-                <a:latin typeface="Calibri"/>
-              </a:rPr>
-              <a:t>    endpoints — chemistry does that</a:t>
-            </a:r>
-          </a:p>
-          <a:p>
-            <a:pPr algn="l">
-              <a:spcAft>
-                <a:spcPts val="400"/>
-              </a:spcAft>
-            </a:pPr>
-            <a:r>
-              <a:rPr sz="1400" b="0" i="0">
-                <a:solidFill>
-                  <a:srgbClr val="1A1A1A"/>
-                </a:solidFill>
-                <a:latin typeface="Calibri"/>
-              </a:rPr>
-              <a:t/>
-            </a:r>
-          </a:p>
-          <a:p>
-            <a:pPr algn="l">
-              <a:spcAft>
-                <a:spcPts val="400"/>
-              </a:spcAft>
-            </a:pPr>
-            <a:r>
-              <a:rPr sz="1400" b="0" i="0">
-                <a:solidFill>
-                  <a:srgbClr val="1A1A1A"/>
-                </a:solidFill>
-                <a:latin typeface="Calibri"/>
-              </a:rPr>
-              <a:t>•  Fusion does not help — we independently</a:t>
-            </a:r>
-          </a:p>
-          <a:p>
-            <a:pPr algn="l">
-              <a:spcAft>
-                <a:spcPts val="400"/>
-              </a:spcAft>
-            </a:pPr>
-            <a:r>
-              <a:rPr sz="1400" b="0" i="0">
-                <a:solidFill>
-                  <a:srgbClr val="1A1A1A"/>
-                </a:solidFill>
-                <a:latin typeface="Calibri"/>
-              </a:rPr>
-              <a:t>    replicate the main analysis</a:t>
-            </a:r>
-          </a:p>
-          <a:p>
-            <a:pPr algn="l">
-              <a:spcAft>
-                <a:spcPts val="400"/>
-              </a:spcAft>
-            </a:pPr>
-            <a:r>
-              <a:rPr sz="1400" b="0" i="0">
-                <a:solidFill>
-                  <a:srgbClr val="1A1A1A"/>
-                </a:solidFill>
-                <a:latin typeface="Calibri"/>
-              </a:rPr>
-              <a:t/>
-            </a:r>
-          </a:p>
-          <a:p>
-            <a:pPr algn="l">
-              <a:spcAft>
-                <a:spcPts val="400"/>
-              </a:spcAft>
-            </a:pPr>
-            <a:r>
-              <a:rPr sz="1400" b="0" i="0">
-                <a:solidFill>
-                  <a:srgbClr val="1A1A1A"/>
-                </a:solidFill>
-                <a:latin typeface="Calibri"/>
-              </a:rPr>
-              <a:t>•  The modalities agree weakly but really</a:t>
-            </a:r>
-          </a:p>
-          <a:p>
-            <a:pPr algn="l">
-              <a:spcAft>
-                <a:spcPts val="400"/>
-              </a:spcAft>
-            </a:pPr>
-            <a:r>
-              <a:rPr sz="1400" b="0" i="0">
-                <a:solidFill>
-                  <a:srgbClr val="1A1A1A"/>
-                </a:solidFill>
-                <a:latin typeface="Calibri"/>
-              </a:rPr>
-              <a:t>    (adjusted RV 0.016, Mantel p = 0.0001)</a:t>
-            </a:r>
-          </a:p>
-          <a:p>
-            <a:pPr algn="l">
-              <a:spcAft>
-                <a:spcPts val="400"/>
-              </a:spcAft>
-            </a:pPr>
-            <a:r>
-              <a:rPr sz="1400" b="0" i="0">
-                <a:solidFill>
-                  <a:srgbClr val="1A1A1A"/>
-                </a:solidFill>
-                <a:latin typeface="Calibri"/>
-              </a:rPr>
-              <a:t/>
-            </a:r>
-          </a:p>
-          <a:p>
-            <a:pPr algn="l">
-              <a:spcAft>
-                <a:spcPts val="400"/>
-              </a:spcAft>
-            </a:pPr>
-            <a:r>
-              <a:rPr sz="1400" b="0" i="0">
-                <a:solidFill>
-                  <a:srgbClr val="1A1A1A"/>
-                </a:solidFill>
-                <a:latin typeface="Calibri"/>
-              </a:rPr>
-              <a:t>•  Dropping to 2,000 HVGs costs 16× what</a:t>
-            </a:r>
-          </a:p>
-          <a:p>
-            <a:pPr algn="l">
-              <a:spcAft>
-                <a:spcPts val="400"/>
-              </a:spcAft>
-            </a:pPr>
-            <a:r>
-              <a:rPr sz="1400" b="0" i="0">
-                <a:solidFill>
-                  <a:srgbClr val="1A1A1A"/>
-                </a:solidFill>
-                <a:latin typeface="Calibri"/>
-              </a:rPr>
-              <a:t>    its leakage was worth</a:t>
+                  <a:srgbClr val="5A5A58"/>
+                </a:solidFill>
+                <a:latin typeface="Calibri"/>
+              </a:rPr>
+              <a:t>Several of these controls changed our own conclusions — that is the point.</a:t>
             </a:r>
           </a:p>
         </p:txBody>
@@ -5648,8 +5603,8 @@
         </p:nvSpPr>
         <p:spPr>
           <a:xfrm>
-            <a:off x="6309360" y="1325880"/>
-            <a:ext cx="5394960" cy="4206240"/>
+            <a:off x="640080" y="1463040"/>
+            <a:ext cx="5394960" cy="4114800"/>
           </a:xfrm>
           <a:prstGeom prst="rect">
             <a:avLst/>
@@ -5670,11 +5625,11 @@
             <a:r>
               <a:rPr sz="1400" b="0" i="0">
                 <a:solidFill>
-                  <a:srgbClr val="B02418"/>
-                </a:solidFill>
-                <a:latin typeface="Calibri"/>
-              </a:rPr>
-              <a:t>WE MUST NOT SAY</a:t>
+                  <a:srgbClr val="1A1A1A"/>
+                </a:solidFill>
+                <a:latin typeface="Calibri"/>
+              </a:rPr>
+              <a:t>WE CAN SAY</a:t>
             </a:r>
           </a:p>
           <a:p>
@@ -5686,7 +5641,7 @@
             <a:r>
               <a:rPr sz="1400" b="0" i="0">
                 <a:solidFill>
-                  <a:srgbClr val="B02418"/>
+                  <a:srgbClr val="1A1A1A"/>
                 </a:solidFill>
                 <a:latin typeface="Calibri"/>
               </a:rPr>
@@ -5702,11 +5657,11 @@
             <a:r>
               <a:rPr sz="1400" b="0" i="0">
                 <a:solidFill>
-                  <a:srgbClr val="B02418"/>
-                </a:solidFill>
-                <a:latin typeface="Calibri"/>
-              </a:rPr>
-              <a:t>•  Any plain RV number — it scores random</a:t>
+                  <a:srgbClr val="1A1A1A"/>
+                </a:solidFill>
+                <a:latin typeface="Calibri"/>
+              </a:rPr>
+              <a:t>•  Morphology adds +0.143 over chemical</a:t>
             </a:r>
           </a:p>
           <a:p>
@@ -5718,11 +5673,11 @@
             <a:r>
               <a:rPr sz="1400" b="0" i="0">
                 <a:solidFill>
-                  <a:srgbClr val="B02418"/>
-                </a:solidFill>
-                <a:latin typeface="Calibri"/>
-              </a:rPr>
-              <a:t>    noise as high as our real data</a:t>
+                  <a:srgbClr val="1A1A1A"/>
+                </a:solidFill>
+                <a:latin typeface="Calibri"/>
+              </a:rPr>
+              <a:t>    structure for mechanism, 4 of 4 models</a:t>
             </a:r>
           </a:p>
           <a:p>
@@ -5734,7 +5689,7 @@
             <a:r>
               <a:rPr sz="1400" b="0" i="0">
                 <a:solidFill>
-                  <a:srgbClr val="B02418"/>
+                  <a:srgbClr val="1A1A1A"/>
                 </a:solidFill>
                 <a:latin typeface="Calibri"/>
               </a:rPr>
@@ -5750,11 +5705,11 @@
             <a:r>
               <a:rPr sz="1400" b="0" i="0">
                 <a:solidFill>
-                  <a:srgbClr val="B02418"/>
-                </a:solidFill>
-                <a:latin typeface="Calibri"/>
-              </a:rPr>
-              <a:t>•  "r = 0.903" — its own null reaches 0.902.</a:t>
+                  <a:srgbClr val="1A1A1A"/>
+                </a:solidFill>
+                <a:latin typeface="Calibri"/>
+              </a:rPr>
+              <a:t>•  It adds nothing for the five toxicity</a:t>
             </a:r>
           </a:p>
           <a:p>
@@ -5766,11 +5721,11 @@
             <a:r>
               <a:rPr sz="1400" b="0" i="0">
                 <a:solidFill>
-                  <a:srgbClr val="B02418"/>
-                </a:solidFill>
-                <a:latin typeface="Calibri"/>
-              </a:rPr>
-              <a:t>    Quote the p-value (0.017)</a:t>
+                  <a:srgbClr val="1A1A1A"/>
+                </a:solidFill>
+                <a:latin typeface="Calibri"/>
+              </a:rPr>
+              <a:t>    endpoints — chemistry does that</a:t>
             </a:r>
           </a:p>
           <a:p>
@@ -5782,7 +5737,7 @@
             <a:r>
               <a:rPr sz="1400" b="0" i="0">
                 <a:solidFill>
-                  <a:srgbClr val="B02418"/>
+                  <a:srgbClr val="1A1A1A"/>
                 </a:solidFill>
                 <a:latin typeface="Calibri"/>
               </a:rPr>
@@ -5798,11 +5753,11 @@
             <a:r>
               <a:rPr sz="1400" b="0" i="0">
                 <a:solidFill>
-                  <a:srgbClr val="B02418"/>
-                </a:solidFill>
-                <a:latin typeface="Calibri"/>
-              </a:rPr>
-              <a:t>•  "Four joint components" — the null also</a:t>
+                  <a:srgbClr val="1A1A1A"/>
+                </a:solidFill>
+                <a:latin typeface="Calibri"/>
+              </a:rPr>
+              <a:t>•  Fusion does not help — we independently</a:t>
             </a:r>
           </a:p>
           <a:p>
@@ -5814,11 +5769,11 @@
             <a:r>
               <a:rPr sz="1400" b="0" i="0">
                 <a:solidFill>
-                  <a:srgbClr val="B02418"/>
-                </a:solidFill>
-                <a:latin typeface="Calibri"/>
-              </a:rPr>
-              <a:t>    reached four, p = 0.095</a:t>
+                  <a:srgbClr val="1A1A1A"/>
+                </a:solidFill>
+                <a:latin typeface="Calibri"/>
+              </a:rPr>
+              <a:t>    replicate the main analysis</a:t>
             </a:r>
           </a:p>
           <a:p>
@@ -5830,7 +5785,7 @@
             <a:r>
               <a:rPr sz="1400" b="0" i="0">
                 <a:solidFill>
-                  <a:srgbClr val="B02418"/>
+                  <a:srgbClr val="1A1A1A"/>
                 </a:solidFill>
                 <a:latin typeface="Calibri"/>
               </a:rPr>
@@ -5846,11 +5801,11 @@
             <a:r>
               <a:rPr sz="1400" b="0" i="0">
                 <a:solidFill>
-                  <a:srgbClr val="B02418"/>
-                </a:solidFill>
-                <a:latin typeface="Calibri"/>
-              </a:rPr>
-              <a:t>•  Any gene list — 0 of 41,780 survive</a:t>
+                  <a:srgbClr val="1A1A1A"/>
+                </a:solidFill>
+                <a:latin typeface="Calibri"/>
+              </a:rPr>
+              <a:t>•  The modalities agree weakly but really</a:t>
             </a:r>
           </a:p>
           <a:p>
@@ -5862,11 +5817,11 @@
             <a:r>
               <a:rPr sz="1400" b="0" i="0">
                 <a:solidFill>
-                  <a:srgbClr val="B02418"/>
-                </a:solidFill>
-                <a:latin typeface="Calibri"/>
-              </a:rPr>
-              <a:t/>
+                  <a:srgbClr val="1A1A1A"/>
+                </a:solidFill>
+                <a:latin typeface="Calibri"/>
+              </a:rPr>
+              <a:t>    (adjusted RV 0.016, Mantel p = 0.0001)</a:t>
             </a:r>
           </a:p>
           <a:p>
@@ -5878,11 +5833,11 @@
             <a:r>
               <a:rPr sz="1400" b="0" i="0">
                 <a:solidFill>
-                  <a:srgbClr val="B02418"/>
-                </a:solidFill>
-                <a:latin typeface="Calibri"/>
-              </a:rPr>
-              <a:t>•  Anything about A549 — its morphology</a:t>
+                  <a:srgbClr val="1A1A1A"/>
+                </a:solidFill>
+                <a:latin typeface="Calibri"/>
+              </a:rPr>
+              <a:t/>
             </a:r>
           </a:p>
           <a:p>
@@ -5894,10 +5849,289 @@
             <a:r>
               <a:rPr sz="1400" b="0" i="0">
                 <a:solidFill>
+                  <a:srgbClr val="1A1A1A"/>
+                </a:solidFill>
+                <a:latin typeface="Calibri"/>
+              </a:rPr>
+              <a:t>•  Dropping to 2,000 HVGs costs 16× what</a:t>
+            </a:r>
+          </a:p>
+          <a:p>
+            <a:pPr algn="l">
+              <a:spcAft>
+                <a:spcPts val="400"/>
+              </a:spcAft>
+            </a:pPr>
+            <a:r>
+              <a:rPr sz="1400" b="0" i="0">
+                <a:solidFill>
+                  <a:srgbClr val="1A1A1A"/>
+                </a:solidFill>
+                <a:latin typeface="Calibri"/>
+              </a:rPr>
+              <a:t>    its leakage was worth</a:t>
+            </a:r>
+          </a:p>
+        </p:txBody>
+      </p:sp>
+      <p:sp>
+        <p:nvSpPr>
+          <p:cNvPr id="5" name="TextBox 4"/>
+          <p:cNvSpPr txBox="1"/>
+          <p:nvPr/>
+        </p:nvSpPr>
+        <p:spPr>
+          <a:xfrm>
+            <a:off x="6309360" y="1463040"/>
+            <a:ext cx="5394960" cy="4114800"/>
+          </a:xfrm>
+          <a:prstGeom prst="rect">
+            <a:avLst/>
+          </a:prstGeom>
+          <a:noFill/>
+        </p:spPr>
+        <p:txBody>
+          <a:bodyPr wrap="square" anchor="t">
+            <a:spAutoFit/>
+          </a:bodyPr>
+          <a:lstStyle/>
+          <a:p>
+            <a:pPr algn="l">
+              <a:spcAft>
+                <a:spcPts val="400"/>
+              </a:spcAft>
+            </a:pPr>
+            <a:r>
+              <a:rPr sz="1400" b="0" i="0">
+                <a:solidFill>
                   <a:srgbClr val="B02418"/>
                 </a:solidFill>
                 <a:latin typeface="Calibri"/>
               </a:rPr>
+              <a:t>WE MUST NOT SAY</a:t>
+            </a:r>
+          </a:p>
+          <a:p>
+            <a:pPr algn="l">
+              <a:spcAft>
+                <a:spcPts val="400"/>
+              </a:spcAft>
+            </a:pPr>
+            <a:r>
+              <a:rPr sz="1400" b="0" i="0">
+                <a:solidFill>
+                  <a:srgbClr val="B02418"/>
+                </a:solidFill>
+                <a:latin typeface="Calibri"/>
+              </a:rPr>
+              <a:t/>
+            </a:r>
+          </a:p>
+          <a:p>
+            <a:pPr algn="l">
+              <a:spcAft>
+                <a:spcPts val="400"/>
+              </a:spcAft>
+            </a:pPr>
+            <a:r>
+              <a:rPr sz="1400" b="0" i="0">
+                <a:solidFill>
+                  <a:srgbClr val="B02418"/>
+                </a:solidFill>
+                <a:latin typeface="Calibri"/>
+              </a:rPr>
+              <a:t>•  Any plain RV number — it scores random</a:t>
+            </a:r>
+          </a:p>
+          <a:p>
+            <a:pPr algn="l">
+              <a:spcAft>
+                <a:spcPts val="400"/>
+              </a:spcAft>
+            </a:pPr>
+            <a:r>
+              <a:rPr sz="1400" b="0" i="0">
+                <a:solidFill>
+                  <a:srgbClr val="B02418"/>
+                </a:solidFill>
+                <a:latin typeface="Calibri"/>
+              </a:rPr>
+              <a:t>    noise as high as our real data</a:t>
+            </a:r>
+          </a:p>
+          <a:p>
+            <a:pPr algn="l">
+              <a:spcAft>
+                <a:spcPts val="400"/>
+              </a:spcAft>
+            </a:pPr>
+            <a:r>
+              <a:rPr sz="1400" b="0" i="0">
+                <a:solidFill>
+                  <a:srgbClr val="B02418"/>
+                </a:solidFill>
+                <a:latin typeface="Calibri"/>
+              </a:rPr>
+              <a:t/>
+            </a:r>
+          </a:p>
+          <a:p>
+            <a:pPr algn="l">
+              <a:spcAft>
+                <a:spcPts val="400"/>
+              </a:spcAft>
+            </a:pPr>
+            <a:r>
+              <a:rPr sz="1400" b="0" i="0">
+                <a:solidFill>
+                  <a:srgbClr val="B02418"/>
+                </a:solidFill>
+                <a:latin typeface="Calibri"/>
+              </a:rPr>
+              <a:t>•  "r = 0.903" — its own null reaches 0.902.</a:t>
+            </a:r>
+          </a:p>
+          <a:p>
+            <a:pPr algn="l">
+              <a:spcAft>
+                <a:spcPts val="400"/>
+              </a:spcAft>
+            </a:pPr>
+            <a:r>
+              <a:rPr sz="1400" b="0" i="0">
+                <a:solidFill>
+                  <a:srgbClr val="B02418"/>
+                </a:solidFill>
+                <a:latin typeface="Calibri"/>
+              </a:rPr>
+              <a:t>    Quote the p-value (0.017)</a:t>
+            </a:r>
+          </a:p>
+          <a:p>
+            <a:pPr algn="l">
+              <a:spcAft>
+                <a:spcPts val="400"/>
+              </a:spcAft>
+            </a:pPr>
+            <a:r>
+              <a:rPr sz="1400" b="0" i="0">
+                <a:solidFill>
+                  <a:srgbClr val="B02418"/>
+                </a:solidFill>
+                <a:latin typeface="Calibri"/>
+              </a:rPr>
+              <a:t/>
+            </a:r>
+          </a:p>
+          <a:p>
+            <a:pPr algn="l">
+              <a:spcAft>
+                <a:spcPts val="400"/>
+              </a:spcAft>
+            </a:pPr>
+            <a:r>
+              <a:rPr sz="1400" b="0" i="0">
+                <a:solidFill>
+                  <a:srgbClr val="B02418"/>
+                </a:solidFill>
+                <a:latin typeface="Calibri"/>
+              </a:rPr>
+              <a:t>•  "Four joint components" — the null also</a:t>
+            </a:r>
+          </a:p>
+          <a:p>
+            <a:pPr algn="l">
+              <a:spcAft>
+                <a:spcPts val="400"/>
+              </a:spcAft>
+            </a:pPr>
+            <a:r>
+              <a:rPr sz="1400" b="0" i="0">
+                <a:solidFill>
+                  <a:srgbClr val="B02418"/>
+                </a:solidFill>
+                <a:latin typeface="Calibri"/>
+              </a:rPr>
+              <a:t>    reached four, p = 0.095</a:t>
+            </a:r>
+          </a:p>
+          <a:p>
+            <a:pPr algn="l">
+              <a:spcAft>
+                <a:spcPts val="400"/>
+              </a:spcAft>
+            </a:pPr>
+            <a:r>
+              <a:rPr sz="1400" b="0" i="0">
+                <a:solidFill>
+                  <a:srgbClr val="B02418"/>
+                </a:solidFill>
+                <a:latin typeface="Calibri"/>
+              </a:rPr>
+              <a:t/>
+            </a:r>
+          </a:p>
+          <a:p>
+            <a:pPr algn="l">
+              <a:spcAft>
+                <a:spcPts val="400"/>
+              </a:spcAft>
+            </a:pPr>
+            <a:r>
+              <a:rPr sz="1400" b="0" i="0">
+                <a:solidFill>
+                  <a:srgbClr val="B02418"/>
+                </a:solidFill>
+                <a:latin typeface="Calibri"/>
+              </a:rPr>
+              <a:t>•  Any gene list — 0 of 41,780 survive</a:t>
+            </a:r>
+          </a:p>
+          <a:p>
+            <a:pPr algn="l">
+              <a:spcAft>
+                <a:spcPts val="400"/>
+              </a:spcAft>
+            </a:pPr>
+            <a:r>
+              <a:rPr sz="1400" b="0" i="0">
+                <a:solidFill>
+                  <a:srgbClr val="B02418"/>
+                </a:solidFill>
+                <a:latin typeface="Calibri"/>
+              </a:rPr>
+              <a:t/>
+            </a:r>
+          </a:p>
+          <a:p>
+            <a:pPr algn="l">
+              <a:spcAft>
+                <a:spcPts val="400"/>
+              </a:spcAft>
+            </a:pPr>
+            <a:r>
+              <a:rPr sz="1400" b="0" i="0">
+                <a:solidFill>
+                  <a:srgbClr val="B02418"/>
+                </a:solidFill>
+                <a:latin typeface="Calibri"/>
+              </a:rPr>
+              <a:t>•  Anything about A549 — its morphology</a:t>
+            </a:r>
+          </a:p>
+          <a:p>
+            <a:pPr algn="l">
+              <a:spcAft>
+                <a:spcPts val="400"/>
+              </a:spcAft>
+            </a:pPr>
+            <a:r>
+              <a:rPr sz="1400" b="0" i="0">
+                <a:solidFill>
+                  <a:srgbClr val="B02418"/>
+                </a:solidFill>
+                <a:latin typeface="Calibri"/>
+              </a:rPr>
               <a:t>    is contaminated (max 1.5e19)</a:t>
             </a:r>
           </a:p>
@@ -5905,7 +6139,7 @@
       </p:sp>
       <p:sp>
         <p:nvSpPr>
-          <p:cNvPr id="5" name="TextBox 4"/>
+          <p:cNvPr id="6" name="TextBox 5"/>
           <p:cNvSpPr txBox="1"/>
           <p:nvPr/>
         </p:nvSpPr>

</xml_diff>

<commit_message>
WS4A: signal-map slide explains shuffled vs unshuffled with a worked example
Two words were carrying all the weight and neither was defined on the slide: 'model'
and 'shuffled'. Added both, plus the worked example that makes the subtraction
concrete -- morphology predicting mechanism got 74.5% right on real answers and 47.7%
with the answers shuffled, and 0.745 - 0.477 = +0.267 is the number in the box. So it
is not accuracy. The shuffled run was 47.7% rather than 50%, which is why every box is
compared against its own control.

Co-Authored-By: Claude Opus 5 (1M context) <noreply@anthropic.com>
Claude-Session: https://claude.ai/code/session_01ErS43gfbvnsANcpxm6McXS
</commit_message>
<xml_diff>
--- a/WS4A_presentation_pack/WS4A_slides.pptx
+++ b/WS4A_presentation_pack/WS4A_slides.pptx
@@ -4855,8 +4855,8 @@
         </p:blipFill>
         <p:spPr>
           <a:xfrm>
-            <a:off x="3903481" y="1353312"/>
-            <a:ext cx="4400277" cy="2606040"/>
+            <a:off x="4598262" y="1353312"/>
+            <a:ext cx="3010716" cy="1783080"/>
           </a:xfrm>
           <a:prstGeom prst="rect">
             <a:avLst/>
@@ -4871,8 +4871,8 @@
         </p:nvSpPr>
         <p:spPr>
           <a:xfrm>
-            <a:off x="457200" y="4123944"/>
-            <a:ext cx="11338560" cy="2596896"/>
+            <a:off x="457200" y="3300984"/>
+            <a:ext cx="11338560" cy="3419856"/>
           </a:xfrm>
           <a:prstGeom prst="rect">
             <a:avLst/>
@@ -4891,22 +4891,22 @@
               </a:spcAft>
             </a:pPr>
             <a:r>
-              <a:rPr sz="1150" b="1">
+              <a:rPr sz="1050" b="1">
                 <a:solidFill>
                   <a:srgbClr val="2A78D6"/>
                 </a:solidFill>
                 <a:latin typeface="Calibri"/>
               </a:rPr>
-              <a:t>HOW TO READ IT.  </a:t>
-            </a:r>
-            <a:r>
-              <a:rPr sz="1150">
+              <a:t>WHAT A "MODEL" IS.  </a:t>
+            </a:r>
+            <a:r>
+              <a:rPr sz="1050">
                 <a:solidFill>
                   <a:srgbClr val="1A1A1A"/>
                 </a:solidFill>
                 <a:latin typeface="Calibri"/>
               </a:rPr>
-              <a:t>Rows are the six questions; columns are what the model was allowed to look at. Each cell holds the best of four models, measured as the HONEST GAP — its score on the real answers minus its score when the answers were scrambled. Red = real signal. White = nothing. The small text under each number is how many of the four models independently found it.</a:t>
+              <a:t>A recipe for guessing. We show it drugs whose answer we already know — here are 636 numbers from the photograph, and yes, this one is a DNA-synthesis inhibitor — and it learns a rule. Then it must guess drugs it has NEVER seen. Four different recipes are used on every box: three that draw a dividing line in different ways (elastic net, sparse PLS-DA, linear SVM) and one that builds a flowchart of yes/no questions instead (XGBoost).</a:t>
             </a:r>
           </a:p>
           <a:p>
@@ -4916,22 +4916,22 @@
               </a:spcAft>
             </a:pPr>
             <a:r>
-              <a:rPr sz="1150" b="1">
+              <a:rPr sz="1050" b="1">
                 <a:solidFill>
                   <a:srgbClr val="2A78D6"/>
                 </a:solidFill>
                 <a:latin typeface="Calibri"/>
               </a:rPr>
-              <a:t>WHAT IT SHOWS.  </a:t>
-            </a:r>
-            <a:r>
-              <a:rPr sz="1150">
+              <a:t>SHUFFLED vs UNSHUFFLED — every box is run TWICE.  </a:t>
+            </a:r>
+            <a:r>
+              <a:rPr sz="1050">
                 <a:solidFill>
                   <a:srgbClr val="1A1A1A"/>
                 </a:solidFill>
                 <a:latin typeface="Calibri"/>
               </a:rPr>
-              <a:t>The top row — mechanism of action — is the only row that works across the board. Chemical structure alone gives +0.175; the photograph alone gives +0.267; the two together give +0.318. Now read DOWN the morphology column: every toxicity row is near-white (+0.012, +0.011, +0.008, +0.064, −0.005) with 0 of 4 models finding anything. Meanwhile the chemistry column IS predicting the toxicity endpoints.</a:t>
+              <a:t>UNSHUFFLED: each drug keeps its true answer. SHUFFLED: we deal the answers out at random, so drug A is given drug B's answer — the link between measurements and answer is destroyed on purpose, so there is nothing left to learn. The model still scores something, because with 119 drugs and up to 41,780 measurements some line up with random answers by pure chance. THAT is the luck level, and it differs for every box.</a:t>
             </a:r>
           </a:p>
           <a:p>
@@ -4941,22 +4941,72 @@
               </a:spcAft>
             </a:pPr>
             <a:r>
-              <a:rPr sz="1150" b="1">
+              <a:rPr sz="1050" b="1">
                 <a:solidFill>
                   <a:srgbClr val="2A78D6"/>
                 </a:solidFill>
                 <a:latin typeface="Calibri"/>
               </a:rPr>
-              <a:t>THE POINT.  </a:t>
-            </a:r>
-            <a:r>
-              <a:rPr sz="1150">
+              <a:t>WHERE THE NUMBER IN EACH BOX COMES FROM.  </a:t>
+            </a:r>
+            <a:r>
+              <a:rPr sz="1050">
                 <a:solidFill>
                   <a:srgbClr val="1A1A1A"/>
                 </a:solidFill>
                 <a:latin typeface="Calibri"/>
               </a:rPr>
-              <a:t>Chemistry is the control because it is free — no cells, no microscope, no sequencing — and chemists have predicted drug properties from structure for thirty years. So the question is not whether imaging beats chance, but whether it beats the free option. For MECHANISM it does, adding +0.143 on top of chemistry with all four models agreeing. For TOXICITY it does not.</a:t>
+              <a:t>Worked example — morphology predicting mechanism, the box reading +0.267. The best model got 74.5 % right on the real answers. With the answers shuffled it still got 47.7 %. 0.745 − 0.477 = +0.267, and that difference is what is printed. So the number is NOT accuracy — it is how far the model beat its own shuffled twin. Note the shuffled run was 47.7 %, not 50 %: across the four models in that one box it ranged 47.7–51.7 %, which is why each box is compared against its OWN control rather than against 0.5.</a:t>
+            </a:r>
+          </a:p>
+          <a:p>
+            <a:pPr>
+              <a:spcAft>
+                <a:spcPts val="700"/>
+              </a:spcAft>
+            </a:pPr>
+            <a:r>
+              <a:rPr sz="1050" b="1">
+                <a:solidFill>
+                  <a:srgbClr val="2A78D6"/>
+                </a:solidFill>
+                <a:latin typeface="Calibri"/>
+              </a:rPr>
+              <a:t>HOW TO READ THE GRID.  </a:t>
+            </a:r>
+            <a:r>
+              <a:rPr sz="1050">
+                <a:solidFill>
+                  <a:srgbClr val="1A1A1A"/>
+                </a:solidFill>
+                <a:latin typeface="Calibri"/>
+              </a:rPr>
+              <a:t>Rows are the six questions; columns are what the model was allowed to look at. Red = the model beat its shuffled twin. White = it did not. −0.005 means it did slightly WORSE than nonsense, which is what "nothing here" looks like when measured honestly. The small print — 4/4 models — is how many of the four recipes each independently beat its own shuffled run.</a:t>
+            </a:r>
+          </a:p>
+          <a:p>
+            <a:pPr>
+              <a:spcAft>
+                <a:spcPts val="700"/>
+              </a:spcAft>
+            </a:pPr>
+            <a:r>
+              <a:rPr sz="1050" b="1">
+                <a:solidFill>
+                  <a:srgbClr val="2A78D6"/>
+                </a:solidFill>
+                <a:latin typeface="Calibri"/>
+              </a:rPr>
+              <a:t>WHAT IT SHOWS, AND THE POINT.  </a:t>
+            </a:r>
+            <a:r>
+              <a:rPr sz="1050">
+                <a:solidFill>
+                  <a:srgbClr val="1A1A1A"/>
+                </a:solidFill>
+                <a:latin typeface="Calibri"/>
+              </a:rPr>
+              <a:t>The top row, mechanism of action, is the only row that works across the board: chemistry +0.175, the photograph +0.267, both together +0.318. Read DOWN the morphology column and every toxicity row is near-white with 0 of 4 models finding anything — while the chemistry column IS predicting them. Chemistry is the control because it is free, so the question is not whether imaging beats chance but whether it beats the free option. For MECHANISM it does, by +0.143. For TOXICITY it does not.</a:t>
             </a:r>
           </a:p>
         </p:txBody>

</xml_diff>

<commit_message>
WS4A: explainer panel — where one number in the concordance plot comes from
Five numbered steps with real figures: one combination (6 questions x 5 data types),
four recipes, each run twice with true and randomised answers, subtract, and the four
gaps are one row. Worked on mechanism-from-photograph: 74.5% real, 47.7% randomised,
+0.267 — and the randomised runs ranged 47.7-51.7%, never exactly 50%.

Co-Authored-By: Claude Opus 5 (1M context) <noreply@anthropic.com>
Claude-Session: https://claude.ai/code/session_01ErS43gfbvnsANcpxm6McXS
</commit_message>
<xml_diff>
--- a/WS4A_presentation_pack/WS4A_slides.pptx
+++ b/WS4A_presentation_pack/WS4A_slides.pptx
@@ -11,6 +11,7 @@
     <p:sldId id="259" r:id="rId11"/>
     <p:sldId id="260" r:id="rId12"/>
     <p:sldId id="261" r:id="rId13"/>
+    <p:sldId id="262" r:id="rId14"/>
   </p:sldIdLst>
   <p:sldSz cx="12191695" cy="6858000" type="screen4x3"/>
   <p:notesSz cx="6858000" cy="9144000"/>
@@ -1018,91 +1019,75 @@
           <a:lstStyle/>
           <a:p>
             <a:r>
+              <a:t>USE THIS SLIDE IF ANYONE LOOKS LOST. It is the whole method in one picture, and it is worked with real numbers rather than symbols.</a:t>
+            </a:r>
+          </a:p>
+          <a:p/>
+          <a:p>
+            <a:r>
               <a:t>SAY:</a:t>
             </a:r>
           </a:p>
           <a:p>
             <a:r>
-              <a:t>"The obvious objection to anything from 119 compounds is that we got lucky with one model. So we ran four families that look for structure in genuinely different ways.</a:t>
+              <a:t>"Let me show you exactly where one of these numbers comes from.</a:t>
             </a:r>
           </a:p>
           <a:p/>
           <a:p>
             <a:r>
-              <a:t>On the left, how similarly each pair ranks all thirty combinations. One point zero would be identical ordering. The three linear models — elastic net, linear SVM, sparse PLS-DA — agree at 0.73 to 0.87. They are all variations on drawing a dividing line, so that much agreement is expected.</a:t>
+              <a:t>A combination is one question and one kind of data — mechanism from the photograph, say. There are thirty of those, and each one becomes a row on the next slide.</a:t>
             </a:r>
           </a:p>
           <a:p/>
           <a:p>
             <a:r>
-              <a:t>XGBoost agrees much less, around 0.5. It builds decision trees. And that low number is the interesting one: if all four sat at 0.95 you would have four views of essentially one model, and 'they all agree' would mean nothing. At 0.5, when it does land on the same combinations as the others, that is independent confirmation.</a:t>
+              <a:t>Four different recipes try that combination. Three of them draw a dividing line through the data in different ways; the fourth doesn't draw a line at all, it builds a flowchart of yes/no questions. That difference matters — if all four agree, it isn't a quirk of one method.</a:t>
             </a:r>
           </a:p>
           <a:p/>
           <a:p>
             <a:r>
-              <a:t>On the right, all thirty combinations, sorted by their WEAKEST model — a combination is only as good as the worst of the four. Most of them sit at zero: the signal is concentrated at the top, which is what an honest landscape looks like. In the shaded band, 14 of 30, every single model clears zero — and that band includes mechanism of action from morphology, our headline."</a:t>
+              <a:t>Each recipe runs twice. Once with the true answers. Once with the answers dealt out at random, so drug A gets drug B's answer and there is nothing left to learn. Then we subtract.</a:t>
             </a:r>
           </a:p>
           <a:p/>
           <a:p>
             <a:r>
-              <a:t>WHY THIS SLIDE, AND WHY IT MATTERS MORE THAN A P-VALUE HERE</a:t>
-            </a:r>
-          </a:p>
-          <a:p>
-            <a:r>
-              <a:t>Our uncertainty intervals are anti-conservative — cross-validation folds share training data, so there is no unbiased variance estimate for k-fold CV (Bengio &amp; Grandvalet 2004). Rather than lean on a shaky interval, we lean on four methods with different failure modes agreeing. At this sample size that is the more honest evidence.</a:t>
+              <a:t>Here are the real numbers. The best recipe got 74.5 percent right on the true answers. With the answers randomised it STILL got 47.7 percent — that is what luck alone buys with 119 drugs and 41,780 measurements. 74.5 minus 47.7 is the 0.267 you will see on the next slide.</a:t>
             </a:r>
           </a:p>
           <a:p/>
           <a:p>
             <a:r>
-              <a:t>BE HONEST ABOUT THE ALTERNATIVE READING IF PUSHED</a:t>
-            </a:r>
-          </a:p>
-          <a:p>
-            <a:r>
-              <a:t>A rho of 0.5 for XGBoost can mean two things: it is finding different REAL structure, or it is simply noisier and worse on this data. Both are consistent with 0.5 — XGBoost had 10 degenerate rows in the untuned run and rarely wins a combination. So the safe claim is the narrow one: the three linear models agree strongly, and on the top combinations XGBoost independently clears zero too. Do not oversell the 'different inductive bias' story.</a:t>
+              <a:t>And notice the randomised runs: 47.7, 48.2, 48.5, 51.7. Never exactly fifty. That is why we compare every box against its own randomised control rather than against a coin flip."</a:t>
             </a:r>
           </a:p>
           <a:p/>
           <a:p>
             <a:r>
-              <a:t>WHY SORTED BY THE WEAKEST MODEL: sorting by the mean would scatter the 'all four clear zero' rows through the panel and the shading would read as stripes. Sorting by the minimum makes that set exactly the top block, and it is the conservative ranking anyway.</a:t>
+              <a:t>IF ASKED</a:t>
+            </a:r>
+          </a:p>
+          <a:p>
+            <a:r>
+              <a:t>Q: Why 25 train-test rounds?</a:t>
+            </a:r>
+          </a:p>
+          <a:p>
+            <a:r>
+              <a:t>A: One split could be lucky. We hide a different fifth of the drugs each time and average, so every drug is hidden several times.</a:t>
             </a:r>
           </a:p>
           <a:p/>
           <a:p>
             <a:r>
-              <a:t>IF ASKED WHY ONLY SIX ROWS ARE LABELLED: 30 labels do not read from the back of an auditorium -- the panel is dense, not merely small, so a bigger screen enlarges the rows AND the gaps and never improves the ratio. All 30 rows are still plotted, because you do not need to read a label to see the trend. The fully labelled version is in the pack at 04_methods/08_model_concordance.png.</a:t>
-            </a:r>
-          </a:p>
-          <a:p/>
-          <a:p>
-            <a:r>
-              <a:t>IF ASKED</a:t>
-            </a:r>
-          </a:p>
-          <a:p>
-            <a:r>
-              <a:t>Q: Why not just report a p-value?</a:t>
-            </a:r>
-          </a:p>
-          <a:p>
-            <a:r>
-              <a:t>A: See above — the interval for a k-fold CV mean is not trustworthy at this n. Model consensus is the substitute, and we say so.</a:t>
-            </a:r>
-          </a:p>
-          <a:p/>
-          <a:p>
-            <a:r>
-              <a:t>Q: What happened to the gene-level analysis?</a:t>
-            </a:r>
-          </a:p>
-          <a:p>
-            <a:r>
-              <a:t>A: We have it — a permutation null on the shared morphology-expression axis where 0 of 41,780 genes survive. We left it out because this deck already reports 0 of 1.27 million feature-gene pairs at FDR below 0.05, by a different method. Same conclusion, already covered. It is in the backup.</a:t>
+              <a:t>Q: How many models is that in total?</a:t>
+            </a:r>
+          </a:p>
+          <a:p>
+            <a:r>
+              <a:t>A: 30 combinations x 4 recipes x 2 label conditions x 25 rounds, about 6,000 fits -- and we did the whole thing twice, tuned and untuned.</a:t>
             </a:r>
           </a:p>
         </p:txBody>
@@ -1128,6 +1113,160 @@
 </file>
 
 <file path=ppt/notesSlides/notesSlide6.xml><?xml version="1.0" encoding="utf-8"?>
+<p:notes xmlns:a="http://schemas.openxmlformats.org/drawingml/2006/main" xmlns:p="http://schemas.openxmlformats.org/presentationml/2006/main" xmlns:r="http://schemas.openxmlformats.org/officeDocument/2006/relationships">
+  <p:cSld>
+    <p:spTree>
+      <p:nvGrpSpPr>
+        <p:cNvPr id="1" name=""/>
+        <p:cNvGrpSpPr/>
+        <p:nvPr/>
+      </p:nvGrpSpPr>
+      <p:grpSpPr>
+        <a:xfrm>
+          <a:off x="0" y="0"/>
+          <a:ext cx="0" cy="0"/>
+          <a:chOff x="0" y="0"/>
+          <a:chExt cx="0" cy="0"/>
+        </a:xfrm>
+      </p:grpSpPr>
+      <p:sp>
+        <p:nvSpPr>
+          <p:cNvPr id="2" name="Slide Image Placeholder 1"/>
+          <p:cNvSpPr>
+            <a:spLocks noGrp="1"/>
+          </p:cNvSpPr>
+          <p:nvPr>
+            <p:ph type="sldImg" idx="2"/>
+          </p:nvPr>
+        </p:nvSpPr>
+        <p:spPr/>
+      </p:sp>
+      <p:sp>
+        <p:nvSpPr>
+          <p:cNvPr id="3" name="Notes Placeholder 2"/>
+          <p:cNvSpPr>
+            <a:spLocks noGrp="1"/>
+          </p:cNvSpPr>
+          <p:nvPr>
+            <p:ph type="body" idx="3" sz="quarter"/>
+          </p:nvPr>
+        </p:nvSpPr>
+        <p:spPr/>
+        <p:txBody>
+          <a:bodyPr/>
+          <a:lstStyle/>
+          <a:p>
+            <a:r>
+              <a:t>SAY:</a:t>
+            </a:r>
+          </a:p>
+          <a:p>
+            <a:r>
+              <a:t>"The obvious objection to anything from 119 compounds is that we got lucky with one model. So we ran four families that look for structure in genuinely different ways.</a:t>
+            </a:r>
+          </a:p>
+          <a:p/>
+          <a:p>
+            <a:r>
+              <a:t>On the left, how similarly each pair ranks all thirty combinations. One point zero would be identical ordering. The three linear models — elastic net, linear SVM, sparse PLS-DA — agree at 0.73 to 0.87. They are all variations on drawing a dividing line, so that much agreement is expected.</a:t>
+            </a:r>
+          </a:p>
+          <a:p/>
+          <a:p>
+            <a:r>
+              <a:t>XGBoost agrees much less, around 0.5. It builds decision trees. And that low number is the interesting one: if all four sat at 0.95 you would have four views of essentially one model, and 'they all agree' would mean nothing. At 0.5, when it does land on the same combinations as the others, that is independent confirmation.</a:t>
+            </a:r>
+          </a:p>
+          <a:p/>
+          <a:p>
+            <a:r>
+              <a:t>On the right, all thirty combinations, sorted by their WEAKEST model — a combination is only as good as the worst of the four. Most of them sit at zero: the signal is concentrated at the top, which is what an honest landscape looks like. In the shaded band, 14 of 30, every single model clears zero — and that band includes mechanism of action from morphology, our headline."</a:t>
+            </a:r>
+          </a:p>
+          <a:p/>
+          <a:p>
+            <a:r>
+              <a:t>WHY THIS SLIDE, AND WHY IT MATTERS MORE THAN A P-VALUE HERE</a:t>
+            </a:r>
+          </a:p>
+          <a:p>
+            <a:r>
+              <a:t>Our uncertainty intervals are anti-conservative — cross-validation folds share training data, so there is no unbiased variance estimate for k-fold CV (Bengio &amp; Grandvalet 2004). Rather than lean on a shaky interval, we lean on four methods with different failure modes agreeing. At this sample size that is the more honest evidence.</a:t>
+            </a:r>
+          </a:p>
+          <a:p/>
+          <a:p>
+            <a:r>
+              <a:t>BE HONEST ABOUT THE ALTERNATIVE READING IF PUSHED</a:t>
+            </a:r>
+          </a:p>
+          <a:p>
+            <a:r>
+              <a:t>A rho of 0.5 for XGBoost can mean two things: it is finding different REAL structure, or it is simply noisier and worse on this data. Both are consistent with 0.5 — XGBoost had 10 degenerate rows in the untuned run and rarely wins a combination. So the safe claim is the narrow one: the three linear models agree strongly, and on the top combinations XGBoost independently clears zero too. Do not oversell the 'different inductive bias' story.</a:t>
+            </a:r>
+          </a:p>
+          <a:p/>
+          <a:p>
+            <a:r>
+              <a:t>WHY SORTED BY THE WEAKEST MODEL: sorting by the mean would scatter the 'all four clear zero' rows through the panel and the shading would read as stripes. Sorting by the minimum makes that set exactly the top block, and it is the conservative ranking anyway.</a:t>
+            </a:r>
+          </a:p>
+          <a:p/>
+          <a:p>
+            <a:r>
+              <a:t>IF ASKED WHY ONLY SIX ROWS ARE LABELLED: 30 labels do not read from the back of an auditorium -- the panel is dense, not merely small, so a bigger screen enlarges the rows AND the gaps and never improves the ratio. All 30 rows are still plotted, because you do not need to read a label to see the trend. The fully labelled version is in the pack at 04_methods/08_model_concordance.png.</a:t>
+            </a:r>
+          </a:p>
+          <a:p/>
+          <a:p>
+            <a:r>
+              <a:t>IF ASKED</a:t>
+            </a:r>
+          </a:p>
+          <a:p>
+            <a:r>
+              <a:t>Q: Why not just report a p-value?</a:t>
+            </a:r>
+          </a:p>
+          <a:p>
+            <a:r>
+              <a:t>A: See above — the interval for a k-fold CV mean is not trustworthy at this n. Model consensus is the substitute, and we say so.</a:t>
+            </a:r>
+          </a:p>
+          <a:p/>
+          <a:p>
+            <a:r>
+              <a:t>Q: What happened to the gene-level analysis?</a:t>
+            </a:r>
+          </a:p>
+          <a:p>
+            <a:r>
+              <a:t>A: We have it — a permutation null on the shared morphology-expression axis where 0 of 41,780 genes survive. We left it out because this deck already reports 0 of 1.27 million feature-gene pairs at FDR below 0.05, by a different method. Same conclusion, already covered. It is in the backup.</a:t>
+            </a:r>
+          </a:p>
+        </p:txBody>
+      </p:sp>
+      <p:sp>
+        <p:nvSpPr>
+          <p:cNvPr id="4" name="Slide Number Placeholder 3"/>
+          <p:cNvSpPr>
+            <a:spLocks noGrp="1"/>
+          </p:cNvSpPr>
+          <p:nvPr>
+            <p:ph type="sldNum" idx="5" sz="quarter"/>
+          </p:nvPr>
+        </p:nvSpPr>
+        <p:spPr/>
+      </p:sp>
+    </p:spTree>
+  </p:cSld>
+  <p:clrMapOvr>
+    <a:masterClrMapping/>
+  </p:clrMapOvr>
+</p:notes>
+</file>
+
+<file path=ppt/notesSlides/notesSlide7.xml><?xml version="1.0" encoding="utf-8"?>
 <p:notes xmlns:a="http://schemas.openxmlformats.org/drawingml/2006/main" xmlns:p="http://schemas.openxmlformats.org/presentationml/2006/main" xmlns:r="http://schemas.openxmlformats.org/officeDocument/2006/relationships">
   <p:cSld>
     <p:spTree>
@@ -5336,6 +5475,246 @@
                 </a:solidFill>
                 <a:latin typeface="Calibri"/>
               </a:rPr>
+              <a:t>BEFORE THE NEXT SLIDE  ·  where every number comes from</a:t>
+            </a:r>
+          </a:p>
+        </p:txBody>
+      </p:sp>
+      <p:sp>
+        <p:nvSpPr>
+          <p:cNvPr id="3" name="TextBox 2"/>
+          <p:cNvSpPr txBox="1"/>
+          <p:nvPr/>
+        </p:nvSpPr>
+        <p:spPr>
+          <a:xfrm>
+            <a:off x="457200" y="365760"/>
+            <a:ext cx="11338560" cy="502920"/>
+          </a:xfrm>
+          <a:prstGeom prst="rect">
+            <a:avLst/>
+          </a:prstGeom>
+          <a:noFill/>
+        </p:spPr>
+        <p:txBody>
+          <a:bodyPr wrap="square" anchor="t">
+            <a:spAutoFit/>
+          </a:bodyPr>
+          <a:lstStyle/>
+          <a:p>
+            <a:pPr algn="l">
+              <a:spcAft>
+                <a:spcPts val="400"/>
+              </a:spcAft>
+            </a:pPr>
+            <a:r>
+              <a:rPr sz="2600" b="1" i="0">
+                <a:solidFill>
+                  <a:srgbClr val="1A1A1A"/>
+                </a:solidFill>
+                <a:latin typeface="Calibri"/>
+              </a:rPr>
+              <a:t>One combination, four recipes, run twice — that is one row</a:t>
+            </a:r>
+          </a:p>
+        </p:txBody>
+      </p:sp>
+      <p:sp>
+        <p:nvSpPr>
+          <p:cNvPr id="4" name="TextBox 3"/>
+          <p:cNvSpPr txBox="1"/>
+          <p:nvPr/>
+        </p:nvSpPr>
+        <p:spPr>
+          <a:xfrm>
+            <a:off x="457200" y="896112"/>
+            <a:ext cx="11338560" cy="320040"/>
+          </a:xfrm>
+          <a:prstGeom prst="rect">
+            <a:avLst/>
+          </a:prstGeom>
+          <a:noFill/>
+        </p:spPr>
+        <p:txBody>
+          <a:bodyPr wrap="square" anchor="t">
+            <a:spAutoFit/>
+          </a:bodyPr>
+          <a:lstStyle/>
+          <a:p>
+            <a:pPr algn="l">
+              <a:spcAft>
+                <a:spcPts val="400"/>
+              </a:spcAft>
+            </a:pPr>
+            <a:r>
+              <a:rPr sz="1400" b="0" i="0">
+                <a:solidFill>
+                  <a:srgbClr val="5A5A58"/>
+                </a:solidFill>
+                <a:latin typeface="Calibri"/>
+              </a:rPr>
+              <a:t>The same chain produces every number in this talk. Worked through with real figures from one box.</a:t>
+            </a:r>
+          </a:p>
+        </p:txBody>
+      </p:sp>
+      <p:pic>
+        <p:nvPicPr>
+          <p:cNvPr id="5" name="Picture 4" descr="SLIDE_3b_where_a_row_comes_from.png"/>
+          <p:cNvPicPr>
+            <a:picLocks noChangeAspect="1"/>
+          </p:cNvPicPr>
+          <p:nvPr/>
+        </p:nvPicPr>
+        <p:blipFill>
+          <a:blip r:embed="rId2"/>
+          <a:stretch>
+            <a:fillRect/>
+          </a:stretch>
+        </p:blipFill>
+        <p:spPr>
+          <a:xfrm>
+            <a:off x="3046228" y="1353312"/>
+            <a:ext cx="6114784" cy="3246120"/>
+          </a:xfrm>
+          <a:prstGeom prst="rect">
+            <a:avLst/>
+          </a:prstGeom>
+        </p:spPr>
+      </p:pic>
+      <p:sp>
+        <p:nvSpPr>
+          <p:cNvPr id="6" name="TextBox 5"/>
+          <p:cNvSpPr txBox="1"/>
+          <p:nvPr/>
+        </p:nvSpPr>
+        <p:spPr>
+          <a:xfrm>
+            <a:off x="457200" y="4764023"/>
+            <a:ext cx="11338560" cy="1956816"/>
+          </a:xfrm>
+          <a:prstGeom prst="rect">
+            <a:avLst/>
+          </a:prstGeom>
+          <a:noFill/>
+        </p:spPr>
+        <p:txBody>
+          <a:bodyPr wrap="square">
+            <a:spAutoFit/>
+          </a:bodyPr>
+          <a:lstStyle/>
+          <a:p>
+            <a:pPr>
+              <a:spcAft>
+                <a:spcPts val="700"/>
+              </a:spcAft>
+            </a:pPr>
+            <a:r>
+              <a:rPr sz="1100" b="1">
+                <a:solidFill>
+                  <a:srgbClr val="2A78D6"/>
+                </a:solidFill>
+                <a:latin typeface="Calibri"/>
+              </a:rPr>
+              <a:t>READ IT LEFT TO RIGHT, THEN DOWN.  </a:t>
+            </a:r>
+            <a:r>
+              <a:rPr sz="1100">
+                <a:solidFill>
+                  <a:srgbClr val="1A1A1A"/>
+                </a:solidFill>
+                <a:latin typeface="Calibri"/>
+              </a:rPr>
+              <a:t>A COMBINATION is one question paired with one kind of data — six questions × five data types = 30, and each becomes one row of the next slide. FOUR RECIPES try each combination; three draw a dividing line in different ways and the fourth builds a flowchart instead, so agreement between them is not a quirk of one method. Each recipe is run TWICE — once with the true answers, once with the answers dealt out at random. Subtract, and the four resulting gaps ARE the four dots on one row.</a:t>
+            </a:r>
+          </a:p>
+          <a:p>
+            <a:pPr>
+              <a:spcAft>
+                <a:spcPts val="700"/>
+              </a:spcAft>
+            </a:pPr>
+            <a:r>
+              <a:rPr sz="1100" b="1">
+                <a:solidFill>
+                  <a:srgbClr val="2A78D6"/>
+                </a:solidFill>
+                <a:latin typeface="Calibri"/>
+              </a:rPr>
+              <a:t>THE NUMBERS ARE REAL ONES, FROM THE HEADLINE BOX.  </a:t>
+            </a:r>
+            <a:r>
+              <a:rPr sz="1100">
+                <a:solidFill>
+                  <a:srgbClr val="1A1A1A"/>
+                </a:solidFill>
+                <a:latin typeface="Calibri"/>
+              </a:rPr>
+              <a:t>Mechanism predicted from the photograph. The best recipe got 74.5 % right on the true answers and still got 47.7 % when the answers were randomised, so the honest gap is +0.267. Note the four randomised runs came out at 47.7, 48.2, 48.5 and 51.7 % — never exactly 50 %. That is why each box is measured against its OWN randomised control instead of against a nominal coin flip.</a:t>
+            </a:r>
+          </a:p>
+        </p:txBody>
+      </p:sp>
+    </p:spTree>
+  </p:cSld>
+  <p:clrMapOvr>
+    <a:masterClrMapping/>
+  </p:clrMapOvr>
+</p:sld>
+</file>
+
+<file path=ppt/slides/slide6.xml><?xml version="1.0" encoding="utf-8"?>
+<p:sld xmlns:a="http://schemas.openxmlformats.org/drawingml/2006/main" xmlns:p="http://schemas.openxmlformats.org/presentationml/2006/main" xmlns:r="http://schemas.openxmlformats.org/officeDocument/2006/relationships">
+  <p:cSld>
+    <p:bg>
+      <p:bgPr>
+        <a:solidFill>
+          <a:srgbClr val="FCFCFB"/>
+        </a:solidFill>
+        <a:effectLst/>
+      </p:bgPr>
+    </p:bg>
+    <p:spTree>
+      <p:nvGrpSpPr>
+        <p:cNvPr id="1" name=""/>
+        <p:cNvGrpSpPr/>
+        <p:nvPr/>
+      </p:nvGrpSpPr>
+      <p:grpSpPr/>
+      <p:sp>
+        <p:nvSpPr>
+          <p:cNvPr id="2" name="TextBox 1"/>
+          <p:cNvSpPr txBox="1"/>
+          <p:nvPr/>
+        </p:nvSpPr>
+        <p:spPr>
+          <a:xfrm>
+            <a:off x="457200" y="128016"/>
+            <a:ext cx="11338560" cy="274320"/>
+          </a:xfrm>
+          <a:prstGeom prst="rect">
+            <a:avLst/>
+          </a:prstGeom>
+          <a:noFill/>
+        </p:spPr>
+        <p:txBody>
+          <a:bodyPr wrap="square" anchor="t">
+            <a:spAutoFit/>
+          </a:bodyPr>
+          <a:lstStyle/>
+          <a:p>
+            <a:pPr algn="l">
+              <a:spcAft>
+                <a:spcPts val="400"/>
+              </a:spcAft>
+            </a:pPr>
+            <a:r>
+              <a:rPr sz="1200" b="1" i="0">
+                <a:solidFill>
+                  <a:srgbClr val="2A78D6"/>
+                </a:solidFill>
+                <a:latin typeface="Calibri"/>
+              </a:rPr>
               <a:t>RESULT 3 OF 3  ·  why this is not one lucky model</a:t>
             </a:r>
           </a:p>
@@ -5549,7 +5928,7 @@
 </p:sld>
 </file>
 
-<file path=ppt/slides/slide6.xml><?xml version="1.0" encoding="utf-8"?>
+<file path=ppt/slides/slide7.xml><?xml version="1.0" encoding="utf-8"?>
 <p:sld xmlns:a="http://schemas.openxmlformats.org/drawingml/2006/main" xmlns:p="http://schemas.openxmlformats.org/presentationml/2006/main" xmlns:r="http://schemas.openxmlformats.org/officeDocument/2006/relationships">
   <p:cSld>
     <p:bg>

</xml_diff>